<commit_message>
Script v15: friend case — 3 videos for 1,000 subs, 4 videos ~100k views, viewer comments
Co-Authored-By: Claude Opus 5.5 <noreply@anthropic.com>
Claude-Session: https://claude.ai/code/session_013W5anzYXNxdrYCzkjjTgrP
</commit_message>
<xml_diff>
--- a/seminar-20261005/slides/YouTubeセミナー_v11.pptx
+++ b/seminar-20261005/slides/YouTubeセミナー_v11.pptx
@@ -2297,7 +2297,7 @@
           <a:p>
             <a:r>
               <a:rPr lang="en-US" dirty="0"/>
-              <a:t>種明かし。友人の陸上チャンネル（@haman100m、公開の許可あり）。「月10万円稼ぎたい」という相談。(1)俯瞰：陸上の動画を片っ端から。多いのはスパイクのレビュー、練習vlog、速く走るコツ。プロの走りを解説するチャンネルはない。(2)成功ライン：ジャンル平均1〜2万再生。このチャンネルで3〜4年前に出したコールマンの走りの解説が3万再生＝平均より上＝需要あり。その後は本人のvlogになっていた。(3)激戦区：スパイクレビュー・vlog系。(4)空いている場所：プロの走りの徹底解説→「これなら勝てる」。</a:t>
+              <a:t>種明かし。友人の陸上チャンネル（@haman100m、公開の許可あり）。「月10万円稼ぎたい」という相談。(1)俯瞰：陸上の動画を片っ端から。多いのはスパイクのレビュー、練習vlog、速く走るコツ。プロの走りを解説するチャンネルはない。(2)成功ライン：ジャンル平均1〜2万再生。このチャンネルで3〜4年前に出したコールマンの走りの解説が3万再生＝平均より上＝需要あり。その後は本人のvlogになっていた。(3)激戦区：スパイクレビュー・vlog系。(4)空いている場所：プロの走りの徹底解説→「これなら勝てる」。結果：3本目で登録者1,000人以上増・4,000時間の見込み→4本目を出して、4本で合計10万再生近く。コメントに「すごく分かりやすい」。</a:t>
             </a:r>
             <a:endParaRPr lang="en-US" dirty="0"/>
           </a:p>
@@ -11488,6 +11488,10 @@
           </a:solidFill>
           <a:ln/>
         </p:spPr>
+        <p:txBody>
+          <a:bodyPr/>
+          <a:p/>
+        </p:txBody>
       </p:sp>
       <p:sp>
         <p:nvSpPr>
@@ -11646,6 +11650,10 @@
           </a:solidFill>
           <a:ln/>
         </p:spPr>
+        <p:txBody>
+          <a:bodyPr/>
+          <a:p/>
+        </p:txBody>
       </p:sp>
       <p:sp>
         <p:nvSpPr>
@@ -11804,6 +11812,10 @@
           </a:solidFill>
           <a:ln/>
         </p:spPr>
+        <p:txBody>
+          <a:bodyPr/>
+          <a:p/>
+        </p:txBody>
       </p:sp>
       <p:sp>
         <p:nvSpPr>
@@ -11962,6 +11974,10 @@
           </a:solidFill>
           <a:ln/>
         </p:spPr>
+        <p:txBody>
+          <a:bodyPr/>
+          <a:p/>
+        </p:txBody>
       </p:sp>
       <p:sp>
         <p:nvSpPr>
@@ -12134,7 +12150,7 @@
                 <a:ea typeface="Meiryo" pitchFamily="34" charset="-122"/>
                 <a:cs typeface="Meiryo" pitchFamily="34" charset="-120"/>
               </a:rPr>
-              <a:t>この道筋の動画で、登録者1,000人以上増・4,000時間を達成</a:t>
+              <a:t>3本で登録者1,000人以上増・4,000時間達成。4本で合計10万再生</a:t>
             </a:r>
             <a:endParaRPr lang="en-US" sz="1900" dirty="0"/>
           </a:p>

</xml_diff>